<commit_message>
updated ppt and pdf files
</commit_message>
<xml_diff>
--- a/05_06/06_eloadas_Backend_REST_fejlesztes.pptx
+++ b/05_06/06_eloadas_Backend_REST_fejlesztes.pptx
@@ -214,7 +214,7 @@
           <a:p>
             <a:fld id="{4C482E4E-5CEC-44A9-BF2B-512FB3B5604F}" type="datetimeFigureOut">
               <a:rPr lang="en-US" smtClean="0"/>
-              <a:t>1/12/2026</a:t>
+              <a:t>3/8/2026</a:t>
             </a:fld>
             <a:endParaRPr lang="en-US"/>
           </a:p>
@@ -1498,7 +1498,7 @@
             </a:r>
             <a:r>
               <a:rPr lang="hu-HU" dirty="0"/>
-              <a:t>/</a:t>
+              <a:t>/v1/</a:t>
             </a:r>
             <a:r>
               <a:rPr lang="hu-HU" dirty="0" err="1"/>
@@ -1713,7 +1713,7 @@
                 <a:ea typeface="+mn-ea"/>
                 <a:cs typeface="+mn-cs"/>
               </a:rPr>
-              <a:t>/</a:t>
+              <a:t>/v1/</a:t>
             </a:r>
             <a:r>
               <a:rPr lang="hu-HU" sz="1200" b="1" kern="1200" dirty="0" err="1">
@@ -6183,7 +6183,7 @@
           <a:p>
             <a:fld id="{E80C50CD-E178-4744-9B35-B2F624D6C5E9}" type="datetimeFigureOut">
               <a:rPr lang="en-US" smtClean="0"/>
-              <a:t>1/12/2026</a:t>
+              <a:t>3/8/2026</a:t>
             </a:fld>
             <a:endParaRPr lang="en-US"/>
           </a:p>
@@ -6381,7 +6381,7 @@
           <a:p>
             <a:fld id="{E80C50CD-E178-4744-9B35-B2F624D6C5E9}" type="datetimeFigureOut">
               <a:rPr lang="en-US" smtClean="0"/>
-              <a:t>1/12/2026</a:t>
+              <a:t>3/8/2026</a:t>
             </a:fld>
             <a:endParaRPr lang="en-US"/>
           </a:p>
@@ -6589,7 +6589,7 @@
           <a:p>
             <a:fld id="{E80C50CD-E178-4744-9B35-B2F624D6C5E9}" type="datetimeFigureOut">
               <a:rPr lang="en-US" smtClean="0"/>
-              <a:t>1/12/2026</a:t>
+              <a:t>3/8/2026</a:t>
             </a:fld>
             <a:endParaRPr lang="en-US"/>
           </a:p>
@@ -6839,7 +6839,7 @@
           <a:p>
             <a:fld id="{E80C50CD-E178-4744-9B35-B2F624D6C5E9}" type="datetimeFigureOut">
               <a:rPr lang="en-US" smtClean="0"/>
-              <a:t>1/12/2026</a:t>
+              <a:t>3/8/2026</a:t>
             </a:fld>
             <a:endParaRPr lang="en-US"/>
           </a:p>
@@ -7118,7 +7118,7 @@
           <a:p>
             <a:fld id="{E80C50CD-E178-4744-9B35-B2F624D6C5E9}" type="datetimeFigureOut">
               <a:rPr lang="en-US" smtClean="0"/>
-              <a:t>1/12/2026</a:t>
+              <a:t>3/8/2026</a:t>
             </a:fld>
             <a:endParaRPr lang="en-US"/>
           </a:p>
@@ -7435,7 +7435,7 @@
           <a:p>
             <a:fld id="{E80C50CD-E178-4744-9B35-B2F624D6C5E9}" type="datetimeFigureOut">
               <a:rPr lang="en-US" smtClean="0"/>
-              <a:t>1/12/2026</a:t>
+              <a:t>3/8/2026</a:t>
             </a:fld>
             <a:endParaRPr lang="en-US"/>
           </a:p>
@@ -7851,7 +7851,7 @@
           <a:p>
             <a:fld id="{E80C50CD-E178-4744-9B35-B2F624D6C5E9}" type="datetimeFigureOut">
               <a:rPr lang="en-US" smtClean="0"/>
-              <a:t>1/12/2026</a:t>
+              <a:t>3/8/2026</a:t>
             </a:fld>
             <a:endParaRPr lang="en-US"/>
           </a:p>
@@ -7992,7 +7992,7 @@
           <a:p>
             <a:fld id="{E80C50CD-E178-4744-9B35-B2F624D6C5E9}" type="datetimeFigureOut">
               <a:rPr lang="en-US" smtClean="0"/>
-              <a:t>1/12/2026</a:t>
+              <a:t>3/8/2026</a:t>
             </a:fld>
             <a:endParaRPr lang="en-US"/>
           </a:p>
@@ -8105,7 +8105,7 @@
           <a:p>
             <a:fld id="{E80C50CD-E178-4744-9B35-B2F624D6C5E9}" type="datetimeFigureOut">
               <a:rPr lang="en-US" smtClean="0"/>
-              <a:t>1/12/2026</a:t>
+              <a:t>3/8/2026</a:t>
             </a:fld>
             <a:endParaRPr lang="en-US"/>
           </a:p>
@@ -8422,7 +8422,7 @@
           <a:p>
             <a:fld id="{E80C50CD-E178-4744-9B35-B2F624D6C5E9}" type="datetimeFigureOut">
               <a:rPr lang="en-US" smtClean="0"/>
-              <a:t>1/12/2026</a:t>
+              <a:t>3/8/2026</a:t>
             </a:fld>
             <a:endParaRPr lang="en-US"/>
           </a:p>
@@ -8714,7 +8714,7 @@
           <a:p>
             <a:fld id="{E80C50CD-E178-4744-9B35-B2F624D6C5E9}" type="datetimeFigureOut">
               <a:rPr lang="en-US" smtClean="0"/>
-              <a:t>1/12/2026</a:t>
+              <a:t>3/8/2026</a:t>
             </a:fld>
             <a:endParaRPr lang="en-US"/>
           </a:p>
@@ -8954,7 +8954,7 @@
             <a:fld id="{E80C50CD-E178-4744-9B35-B2F624D6C5E9}" type="datetimeFigureOut">
               <a:rPr lang="en-US" smtClean="0"/>
               <a:pPr/>
-              <a:t>1/12/2026</a:t>
+              <a:t>3/8/2026</a:t>
             </a:fld>
             <a:endParaRPr lang="en-US"/>
           </a:p>
@@ -11468,7 +11468,7 @@
                 <a:effectLst/>
                 <a:latin typeface="Arial" panose="020B0604020202020204" pitchFamily="34" charset="0"/>
               </a:rPr>
-              <a:t>/</a:t>
+              <a:t>/v1/</a:t>
             </a:r>
             <a:r>
               <a:rPr kumimoji="0" lang="hu-HU" altLang="en-US" sz="2000" b="1" i="0" u="none" strike="noStrike" cap="none" normalizeH="0" baseline="0" dirty="0" err="1">
@@ -12021,6 +12021,10 @@
               <a:t>api</a:t>
             </a:r>
             <a:r>
+              <a:rPr lang="hu-HU" sz="2000" b="1" dirty="0"/>
+              <a:t>/v1</a:t>
+            </a:r>
+            <a:r>
               <a:rPr lang="en-US" sz="2000" b="1" dirty="0"/>
               <a:t>/users</a:t>
             </a:r>
@@ -12214,6 +12218,10 @@
               <a:t>api</a:t>
             </a:r>
             <a:r>
+              <a:rPr lang="hu-HU" sz="2600" b="1" dirty="0"/>
+              <a:t>/v1</a:t>
+            </a:r>
+            <a:r>
               <a:rPr lang="en-US" sz="2600" b="1" dirty="0"/>
               <a:t>/users/{id}</a:t>
             </a:r>
@@ -12402,6 +12410,10 @@
             <a:r>
               <a:rPr lang="en-US" sz="2000" b="1" dirty="0" err="1"/>
               <a:t>api</a:t>
+            </a:r>
+            <a:r>
+              <a:rPr lang="hu-HU" sz="2000" b="1" dirty="0"/>
+              <a:t>/v1</a:t>
             </a:r>
             <a:r>
               <a:rPr lang="en-US" sz="2000" b="1" dirty="0"/>

</xml_diff>